<commit_message>
Add README and requirements for population analysis workflow
</commit_message>
<xml_diff>
--- a/project_reports/Poster/Poster_RiveraruizJose-1-36x48-1.pptx
+++ b/project_reports/Poster/Poster_RiveraruizJose-1-36x48-1.pptx
@@ -210,7 +210,7 @@
             <a:fld id="{CFB1F554-8471-F74E-95A3-3E7FC8AE6388}" type="datetimeFigureOut">
               <a:rPr lang="en-US" smtClean="0"/>
               <a:pPr/>
-              <a:t>5/3/26</a:t>
+              <a:t>5/5/26</a:t>
             </a:fld>
             <a:endParaRPr lang="en-US"/>
           </a:p>
@@ -771,7 +771,7 @@
             <a:fld id="{0C2C9624-8537-344B-A181-774C3CF89A66}" type="datetimeFigureOut">
               <a:rPr lang="en-US" smtClean="0"/>
               <a:pPr/>
-              <a:t>5/3/26</a:t>
+              <a:t>5/5/26</a:t>
             </a:fld>
             <a:endParaRPr lang="en-US"/>
           </a:p>
@@ -936,7 +936,7 @@
             <a:fld id="{0C2C9624-8537-344B-A181-774C3CF89A66}" type="datetimeFigureOut">
               <a:rPr lang="en-US" smtClean="0"/>
               <a:pPr/>
-              <a:t>5/3/26</a:t>
+              <a:t>5/5/26</a:t>
             </a:fld>
             <a:endParaRPr lang="en-US"/>
           </a:p>
@@ -1111,7 +1111,7 @@
             <a:fld id="{0C2C9624-8537-344B-A181-774C3CF89A66}" type="datetimeFigureOut">
               <a:rPr lang="en-US" smtClean="0"/>
               <a:pPr/>
-              <a:t>5/3/26</a:t>
+              <a:t>5/5/26</a:t>
             </a:fld>
             <a:endParaRPr lang="en-US"/>
           </a:p>
@@ -1276,7 +1276,7 @@
             <a:fld id="{0C2C9624-8537-344B-A181-774C3CF89A66}" type="datetimeFigureOut">
               <a:rPr lang="en-US" smtClean="0"/>
               <a:pPr/>
-              <a:t>5/3/26</a:t>
+              <a:t>5/5/26</a:t>
             </a:fld>
             <a:endParaRPr lang="en-US"/>
           </a:p>
@@ -1518,7 +1518,7 @@
             <a:fld id="{0C2C9624-8537-344B-A181-774C3CF89A66}" type="datetimeFigureOut">
               <a:rPr lang="en-US" smtClean="0"/>
               <a:pPr/>
-              <a:t>5/3/26</a:t>
+              <a:t>5/5/26</a:t>
             </a:fld>
             <a:endParaRPr lang="en-US"/>
           </a:p>
@@ -1800,7 +1800,7 @@
             <a:fld id="{0C2C9624-8537-344B-A181-774C3CF89A66}" type="datetimeFigureOut">
               <a:rPr lang="en-US" smtClean="0"/>
               <a:pPr/>
-              <a:t>5/3/26</a:t>
+              <a:t>5/5/26</a:t>
             </a:fld>
             <a:endParaRPr lang="en-US"/>
           </a:p>
@@ -2221,7 +2221,7 @@
             <a:fld id="{0C2C9624-8537-344B-A181-774C3CF89A66}" type="datetimeFigureOut">
               <a:rPr lang="en-US" smtClean="0"/>
               <a:pPr/>
-              <a:t>5/3/26</a:t>
+              <a:t>5/5/26</a:t>
             </a:fld>
             <a:endParaRPr lang="en-US"/>
           </a:p>
@@ -2335,7 +2335,7 @@
             <a:fld id="{0C2C9624-8537-344B-A181-774C3CF89A66}" type="datetimeFigureOut">
               <a:rPr lang="en-US" smtClean="0"/>
               <a:pPr/>
-              <a:t>5/3/26</a:t>
+              <a:t>5/5/26</a:t>
             </a:fld>
             <a:endParaRPr lang="en-US"/>
           </a:p>
@@ -2427,7 +2427,7 @@
             <a:fld id="{0C2C9624-8537-344B-A181-774C3CF89A66}" type="datetimeFigureOut">
               <a:rPr lang="en-US" smtClean="0"/>
               <a:pPr/>
-              <a:t>5/3/26</a:t>
+              <a:t>5/5/26</a:t>
             </a:fld>
             <a:endParaRPr lang="en-US"/>
           </a:p>
@@ -2699,7 +2699,7 @@
             <a:fld id="{0C2C9624-8537-344B-A181-774C3CF89A66}" type="datetimeFigureOut">
               <a:rPr lang="en-US" smtClean="0"/>
               <a:pPr/>
-              <a:t>5/3/26</a:t>
+              <a:t>5/5/26</a:t>
             </a:fld>
             <a:endParaRPr lang="en-US"/>
           </a:p>
@@ -2948,7 +2948,7 @@
             <a:fld id="{0C2C9624-8537-344B-A181-774C3CF89A66}" type="datetimeFigureOut">
               <a:rPr lang="en-US" smtClean="0"/>
               <a:pPr/>
-              <a:t>5/3/26</a:t>
+              <a:t>5/5/26</a:t>
             </a:fld>
             <a:endParaRPr lang="en-US"/>
           </a:p>
@@ -3156,7 +3156,7 @@
             <a:fld id="{0C2C9624-8537-344B-A181-774C3CF89A66}" type="datetimeFigureOut">
               <a:rPr lang="en-US" smtClean="0"/>
               <a:pPr/>
-              <a:t>5/3/26</a:t>
+              <a:t>5/5/26</a:t>
             </a:fld>
             <a:endParaRPr lang="en-US"/>
           </a:p>
@@ -4969,7 +4969,7 @@
               <a:rPr lang="en-US" sz="3400" b="0" baseline="0" dirty="0">
                 <a:latin typeface="Calibri" panose="020F0502020204030204" pitchFamily="34" charset="0"/>
               </a:rPr>
-              <a:t> conditions, and resources allocation.</a:t>
+              <a:t> conditions, and disproportionate resources allocation.</a:t>
             </a:r>
             <a:r>
               <a:rPr lang="en-US" sz="3400" dirty="0">
@@ -4998,7 +4998,7 @@
               <a:rPr lang="en-US" sz="3400" dirty="0">
                 <a:latin typeface="Calibri" panose="020F0502020204030204" pitchFamily="34" charset="0"/>
               </a:rPr>
-              <a:t>predicting</a:t>
+              <a:t>Predicting</a:t>
             </a:r>
             <a:r>
               <a:rPr lang="en-US" sz="3400" b="0" baseline="0" dirty="0">
@@ -5013,10 +5013,16 @@
               <a:buChar char="•"/>
             </a:pPr>
             <a:r>
+              <a:rPr lang="en-US" sz="3400" dirty="0">
+                <a:latin typeface="Calibri" panose="020F0502020204030204" pitchFamily="34" charset="0"/>
+              </a:rPr>
+              <a:t>I</a:t>
+            </a:r>
+            <a:r>
               <a:rPr lang="en-US" sz="3400" b="0" baseline="0" dirty="0">
                 <a:latin typeface="Calibri" panose="020F0502020204030204" pitchFamily="34" charset="0"/>
               </a:rPr>
-              <a:t>identifying vulnerable regions </a:t>
+              <a:t>dentifying vulnerable regions </a:t>
             </a:r>
           </a:p>
           <a:p>
@@ -5025,10 +5031,16 @@
               <a:buChar char="•"/>
             </a:pPr>
             <a:r>
+              <a:rPr lang="en-US" sz="3400" dirty="0">
+                <a:latin typeface="Calibri" panose="020F0502020204030204" pitchFamily="34" charset="0"/>
+              </a:rPr>
+              <a:t>I</a:t>
+            </a:r>
+            <a:r>
               <a:rPr lang="en-US" sz="3400" b="0" baseline="0" dirty="0">
                 <a:latin typeface="Calibri" panose="020F0502020204030204" pitchFamily="34" charset="0"/>
               </a:rPr>
-              <a:t>informing government policy responses</a:t>
+              <a:t>nforming government policy responses</a:t>
             </a:r>
           </a:p>
           <a:p>
@@ -5082,7 +5094,7 @@
         <p:spPr>
           <a:xfrm>
             <a:off x="15548272" y="7311605"/>
-            <a:ext cx="12750799" cy="4512703"/>
+            <a:ext cx="12750799" cy="3958705"/>
           </a:xfrm>
           <a:prstGeom prst="rect">
             <a:avLst/>
@@ -5127,16 +5139,10 @@
               <a:buChar char="•"/>
             </a:pPr>
             <a:r>
-              <a:rPr lang="en-US" sz="3600" dirty="0">
-                <a:latin typeface="Calibri" panose="020F0502020204030204" pitchFamily="34" charset="0"/>
-              </a:rPr>
-              <a:t>n</a:t>
-            </a:r>
-            <a:r>
               <a:rPr lang="en-US" sz="3600" b="0" baseline="0" dirty="0">
                 <a:latin typeface="Calibri" panose="020F0502020204030204" pitchFamily="34" charset="0"/>
               </a:rPr>
-              <a:t>atural disasters (hurricanes &amp; earthquakes)</a:t>
+              <a:t>Natural disasters (hurricanes &amp; earthquakes)</a:t>
             </a:r>
           </a:p>
           <a:p>
@@ -5145,10 +5151,16 @@
               <a:buChar char="•"/>
             </a:pPr>
             <a:r>
+              <a:rPr lang="en-US" sz="3600" dirty="0">
+                <a:latin typeface="Calibri" panose="020F0502020204030204" pitchFamily="34" charset="0"/>
+              </a:rPr>
+              <a:t>S</a:t>
+            </a:r>
+            <a:r>
               <a:rPr lang="en-US" sz="3600" b="0" baseline="0" dirty="0">
                 <a:latin typeface="Calibri" panose="020F0502020204030204" pitchFamily="34" charset="0"/>
               </a:rPr>
-              <a:t>economic conditions </a:t>
+              <a:t>ocioeconomic conditions </a:t>
             </a:r>
           </a:p>
           <a:p>
@@ -5160,7 +5172,7 @@
               <a:rPr lang="en-US" sz="3600" dirty="0">
                 <a:latin typeface="Calibri" panose="020F0502020204030204" pitchFamily="34" charset="0"/>
               </a:rPr>
-              <a:t>government migration </a:t>
+              <a:t>Government migration </a:t>
             </a:r>
             <a:r>
               <a:rPr lang="en-US" sz="3600" b="0" baseline="0" dirty="0">
@@ -5191,15 +5203,6 @@
                 <a:latin typeface="Calibri" panose="020F0502020204030204" pitchFamily="34" charset="0"/>
               </a:rPr>
               <a:t>Assess how policy-relevant factors influence outcomes</a:t>
-            </a:r>
-          </a:p>
-          <a:p>
-            <a:pPr lvl="0"/>
-            <a:r>
-              <a:rPr lang="en-US" sz="3600" b="0" baseline="0" dirty="0">
-                <a:latin typeface="Calibri" panose="020F0502020204030204" pitchFamily="34" charset="0"/>
-              </a:rPr>
-              <a:t>  </a:t>
             </a:r>
           </a:p>
         </p:txBody>
@@ -5328,7 +5331,7 @@
               <a:rPr lang="en-US" sz="3600" b="0" baseline="0" dirty="0">
                 <a:latin typeface="Calibri" panose="020F0502020204030204" pitchFamily="34" charset="0"/>
               </a:rPr>
-              <a:t>Lasso achieves strong out-of-sample results (R² ≈ 0.91) </a:t>
+              <a:t>Lasso achieves strong out-of-sample results </a:t>
             </a:r>
           </a:p>
           <a:p>
@@ -5346,7 +5349,19 @@
               <a:rPr lang="en-US" sz="3600" b="0" baseline="0" dirty="0">
                 <a:latin typeface="Calibri" panose="020F0502020204030204" pitchFamily="34" charset="0"/>
               </a:rPr>
-              <a:t>table across temporal split </a:t>
+              <a:t>table across </a:t>
+            </a:r>
+            <a:r>
+              <a:rPr lang="en-US" sz="3600" dirty="0">
+                <a:latin typeface="Calibri" panose="020F0502020204030204" pitchFamily="34" charset="0"/>
+              </a:rPr>
+              <a:t>data</a:t>
+            </a:r>
+            <a:r>
+              <a:rPr lang="en-US" sz="3600" b="0" baseline="0" dirty="0">
+                <a:latin typeface="Calibri" panose="020F0502020204030204" pitchFamily="34" charset="0"/>
+              </a:rPr>
+              <a:t> split </a:t>
             </a:r>
           </a:p>
           <a:p>
@@ -5376,7 +5391,7 @@
               <a:rPr lang="en-US" sz="3600" b="0" baseline="0" dirty="0">
                 <a:latin typeface="Calibri" panose="020F0502020204030204" pitchFamily="34" charset="0"/>
               </a:rPr>
-              <a:t>hocks amplify existing trends, not create new ones </a:t>
+              <a:t>hocks amplify existing migration trends </a:t>
             </a:r>
           </a:p>
           <a:p>
@@ -5527,7 +5542,7 @@
               <a:rPr lang="en-US" sz="3600" b="0" baseline="0" dirty="0">
                 <a:latin typeface="Calibri" panose="020F0502020204030204" pitchFamily="34" charset="0"/>
               </a:rPr>
-              <a:t>Decline is uneven across regions (South and East more affected as seen on maps below) </a:t>
+              <a:t>Decline is uneven across regions, with the southern region being more affected</a:t>
             </a:r>
           </a:p>
           <a:p>
@@ -5575,7 +5590,7 @@
               <a:rPr lang="en-US" sz="3600" dirty="0">
                 <a:latin typeface="Calibri" panose="020F0502020204030204" pitchFamily="34" charset="0"/>
               </a:rPr>
-              <a:t>natural disasters </a:t>
+              <a:t>Natural disasters </a:t>
             </a:r>
           </a:p>
           <a:p>
@@ -5584,10 +5599,16 @@
               <a:buChar char="•"/>
             </a:pPr>
             <a:r>
+              <a:rPr lang="en-US" sz="3600" dirty="0">
+                <a:latin typeface="Calibri" panose="020F0502020204030204" pitchFamily="34" charset="0"/>
+              </a:rPr>
+              <a:t>M</a:t>
+            </a:r>
+            <a:r>
               <a:rPr lang="en-US" sz="3600" b="0" baseline="0" dirty="0">
                 <a:latin typeface="Calibri" panose="020F0502020204030204" pitchFamily="34" charset="0"/>
               </a:rPr>
-              <a:t>migration patterns </a:t>
+              <a:t>igration patterns </a:t>
             </a:r>
           </a:p>
           <a:p>
@@ -5596,10 +5617,16 @@
               <a:buChar char="•"/>
             </a:pPr>
             <a:r>
+              <a:rPr lang="en-US" sz="3600" dirty="0">
+                <a:latin typeface="Calibri" panose="020F0502020204030204" pitchFamily="34" charset="0"/>
+              </a:rPr>
+              <a:t>E</a:t>
+            </a:r>
+            <a:r>
               <a:rPr lang="en-US" sz="3600" b="0" baseline="0" dirty="0">
                 <a:latin typeface="Calibri" panose="020F0502020204030204" pitchFamily="34" charset="0"/>
               </a:rPr>
-              <a:t>economic opportunity </a:t>
+              <a:t>conomic opportunity </a:t>
             </a:r>
           </a:p>
           <a:p>
@@ -5611,7 +5638,19 @@
               <a:rPr lang="en-US" sz="3600" b="0" baseline="0" dirty="0">
                 <a:latin typeface="Calibri" panose="020F0502020204030204" pitchFamily="34" charset="0"/>
               </a:rPr>
-              <a:t>Safety and social vulnerability factors</a:t>
+              <a:t>Safety and social vulnerability </a:t>
+            </a:r>
+            <a:r>
+              <a:rPr lang="en-US" sz="3600" dirty="0">
+                <a:latin typeface="Calibri" panose="020F0502020204030204" pitchFamily="34" charset="0"/>
+              </a:rPr>
+              <a:t>indicators</a:t>
+            </a:r>
+            <a:r>
+              <a:rPr lang="en-US" sz="3600" b="0" baseline="0" dirty="0">
+                <a:latin typeface="Calibri" panose="020F0502020204030204" pitchFamily="34" charset="0"/>
+              </a:rPr>
+              <a:t> (SVIs)</a:t>
             </a:r>
           </a:p>
           <a:p>
@@ -5674,7 +5713,7 @@
             </a:pPr>
             <a:r>
               <a:rPr lang="en-US" altLang="en-US" sz="3400" b="1" dirty="0">
-                <a:latin typeface="Arial" panose="020B0604020202020204" pitchFamily="34" charset="0"/>
+                <a:latin typeface="Calibri" panose="020F0502020204030204" pitchFamily="34" charset="0"/>
               </a:rPr>
               <a:t>Exploratory Data Analysis: </a:t>
             </a:r>
@@ -5692,7 +5731,7 @@
             </a:pPr>
             <a:r>
               <a:rPr lang="en-US" altLang="en-US" sz="3400" dirty="0">
-                <a:latin typeface="Arial" panose="020B0604020202020204" pitchFamily="34" charset="0"/>
+                <a:latin typeface="Calibri" panose="020F0502020204030204" pitchFamily="34" charset="0"/>
               </a:rPr>
               <a:t>Municipal-level (2010–2023) </a:t>
             </a:r>
@@ -5710,7 +5749,7 @@
             </a:pPr>
             <a:r>
               <a:rPr lang="en-US" altLang="en-US" sz="3400" dirty="0">
-                <a:latin typeface="Arial" panose="020B0604020202020204" pitchFamily="34" charset="0"/>
+                <a:latin typeface="Calibri" panose="020F0502020204030204" pitchFamily="34" charset="0"/>
               </a:rPr>
               <a:t>Economic, safety, demographic, vulnerability, disaster features</a:t>
             </a:r>
@@ -5731,7 +5770,7 @@
                 <a:solidFill>
                   <a:srgbClr val="000000"/>
                 </a:solidFill>
-                <a:latin typeface="Arial" charset="0"/>
+                <a:latin typeface="Calibri" panose="020F0502020204030204" pitchFamily="34" charset="0"/>
                 <a:ea typeface="Arial" charset="0"/>
                 <a:cs typeface="Arial" charset="0"/>
               </a:rPr>
@@ -5739,7 +5778,7 @@
             </a:r>
             <a:r>
               <a:rPr lang="en-US" altLang="en-US" sz="3400" dirty="0">
-                <a:latin typeface="Arial" panose="020B0604020202020204" pitchFamily="34" charset="0"/>
+                <a:latin typeface="Calibri" panose="020F0502020204030204" pitchFamily="34" charset="0"/>
               </a:rPr>
               <a:t> </a:t>
             </a:r>
@@ -5756,7 +5795,7 @@
               <a:buChar char="•"/>
             </a:pPr>
             <a:endParaRPr lang="en-US" altLang="en-US" sz="3400" dirty="0">
-              <a:latin typeface="Arial" panose="020B0604020202020204" pitchFamily="34" charset="0"/>
+              <a:latin typeface="Calibri" panose="020F0502020204030204" pitchFamily="34" charset="0"/>
             </a:endParaRPr>
           </a:p>
           <a:p>
@@ -5772,7 +5811,7 @@
             </a:pPr>
             <a:r>
               <a:rPr lang="en-US" altLang="en-US" sz="3400" b="1" dirty="0">
-                <a:latin typeface="Arial" panose="020B0604020202020204" pitchFamily="34" charset="0"/>
+                <a:latin typeface="Calibri" panose="020F0502020204030204" pitchFamily="34" charset="0"/>
               </a:rPr>
               <a:t>Split: </a:t>
             </a:r>
@@ -5790,7 +5829,7 @@
             </a:pPr>
             <a:r>
               <a:rPr lang="en-US" altLang="en-US" sz="3400" dirty="0">
-                <a:latin typeface="Arial" panose="020B0604020202020204" pitchFamily="34" charset="0"/>
+                <a:latin typeface="Calibri" panose="020F0502020204030204" pitchFamily="34" charset="0"/>
               </a:rPr>
               <a:t>Train ≤ 2018 </a:t>
             </a:r>
@@ -5808,7 +5847,7 @@
             </a:pPr>
             <a:r>
               <a:rPr lang="en-US" altLang="en-US" sz="3400" dirty="0">
-                <a:latin typeface="Arial" panose="020B0604020202020204" pitchFamily="34" charset="0"/>
+                <a:latin typeface="Calibri" panose="020F0502020204030204" pitchFamily="34" charset="0"/>
               </a:rPr>
               <a:t>Validation = 2019 </a:t>
             </a:r>
@@ -5826,7 +5865,7 @@
             </a:pPr>
             <a:r>
               <a:rPr lang="en-US" altLang="en-US" sz="3400" dirty="0">
-                <a:latin typeface="Arial" panose="020B0604020202020204" pitchFamily="34" charset="0"/>
+                <a:latin typeface="Calibri" panose="020F0502020204030204" pitchFamily="34" charset="0"/>
               </a:rPr>
               <a:t>Test ≥ 2020 </a:t>
             </a:r>
@@ -5844,7 +5883,7 @@
             </a:pPr>
             <a:r>
               <a:rPr lang="en-US" altLang="en-US" sz="3400" dirty="0">
-                <a:latin typeface="Arial" panose="020B0604020202020204" pitchFamily="34" charset="0"/>
+                <a:latin typeface="Calibri" panose="020F0502020204030204" pitchFamily="34" charset="0"/>
               </a:rPr>
               <a:t>(chronological → no data leakage) </a:t>
             </a:r>
@@ -5861,7 +5900,7 @@
               <a:buChar char="•"/>
             </a:pPr>
             <a:endParaRPr lang="en-US" altLang="en-US" sz="3400" dirty="0">
-              <a:latin typeface="Arial" panose="020B0604020202020204" pitchFamily="34" charset="0"/>
+              <a:latin typeface="Calibri" panose="020F0502020204030204" pitchFamily="34" charset="0"/>
             </a:endParaRPr>
           </a:p>
           <a:p>
@@ -5877,7 +5916,7 @@
             </a:pPr>
             <a:r>
               <a:rPr lang="en-US" altLang="en-US" sz="3400" b="1" dirty="0">
-                <a:latin typeface="Arial" panose="020B0604020202020204" pitchFamily="34" charset="0"/>
+                <a:latin typeface="Calibri" panose="020F0502020204030204" pitchFamily="34" charset="0"/>
               </a:rPr>
               <a:t>Final Model: </a:t>
             </a:r>
@@ -5895,7 +5934,7 @@
             </a:pPr>
             <a:r>
               <a:rPr lang="en-US" altLang="en-US" sz="3400" dirty="0">
-                <a:latin typeface="Arial" panose="020B0604020202020204" pitchFamily="34" charset="0"/>
+                <a:latin typeface="Calibri" panose="020F0502020204030204" pitchFamily="34" charset="0"/>
               </a:rPr>
               <a:t>Lasso (R² ≈ 0.91) selected for strong out-of-sample performance and interpretability</a:t>
             </a:r>
@@ -5912,7 +5951,7 @@
               <a:buChar char="•"/>
             </a:pPr>
             <a:endParaRPr lang="en-US" altLang="en-US" sz="3400" dirty="0">
-              <a:latin typeface="Arial" panose="020B0604020202020204" pitchFamily="34" charset="0"/>
+              <a:latin typeface="Calibri" panose="020F0502020204030204" pitchFamily="34" charset="0"/>
             </a:endParaRPr>
           </a:p>
           <a:p>
@@ -5928,7 +5967,7 @@
             </a:pPr>
             <a:r>
               <a:rPr lang="en-US" altLang="en-US" sz="3400" b="1" dirty="0">
-                <a:latin typeface="Arial" panose="020B0604020202020204" pitchFamily="34" charset="0"/>
+                <a:latin typeface="Calibri" panose="020F0502020204030204" pitchFamily="34" charset="0"/>
               </a:rPr>
               <a:t>Features: </a:t>
             </a:r>
@@ -5946,7 +5985,7 @@
             </a:pPr>
             <a:r>
               <a:rPr lang="en-US" altLang="en-US" sz="3400" dirty="0">
-                <a:latin typeface="Arial" panose="020B0604020202020204" pitchFamily="34" charset="0"/>
+                <a:latin typeface="Calibri" panose="020F0502020204030204" pitchFamily="34" charset="0"/>
               </a:rPr>
               <a:t>Hurricane and earthquake exposure</a:t>
             </a:r>
@@ -5964,7 +6003,7 @@
             </a:pPr>
             <a:r>
               <a:rPr lang="en-US" altLang="en-US" sz="3400" dirty="0">
-                <a:latin typeface="Arial" panose="020B0604020202020204" pitchFamily="34" charset="0"/>
+                <a:latin typeface="Calibri" panose="020F0502020204030204" pitchFamily="34" charset="0"/>
               </a:rPr>
               <a:t>Crime rates </a:t>
             </a:r>
@@ -5982,7 +6021,7 @@
             </a:pPr>
             <a:r>
               <a:rPr lang="en-US" altLang="en-US" sz="3400" dirty="0">
-                <a:latin typeface="Arial" panose="020B0604020202020204" pitchFamily="34" charset="0"/>
+                <a:latin typeface="Calibri" panose="020F0502020204030204" pitchFamily="34" charset="0"/>
               </a:rPr>
               <a:t>Income &amp; establishment growth </a:t>
             </a:r>
@@ -6000,9 +6039,9 @@
             </a:pPr>
             <a:r>
               <a:rPr lang="en-US" altLang="en-US" sz="3400" dirty="0">
-                <a:latin typeface="Arial" panose="020B0604020202020204" pitchFamily="34" charset="0"/>
-              </a:rPr>
-              <a:t>Social vulnerability indicators (SVIs) </a:t>
+                <a:latin typeface="Calibri" panose="020F0502020204030204" pitchFamily="34" charset="0"/>
+              </a:rPr>
+              <a:t>Social vulnerability indicators </a:t>
             </a:r>
           </a:p>
           <a:p>
@@ -6018,7 +6057,7 @@
             </a:pPr>
             <a:r>
               <a:rPr lang="en-US" altLang="en-US" sz="3400" dirty="0">
-                <a:latin typeface="Arial" panose="020B0604020202020204" pitchFamily="34" charset="0"/>
+                <a:latin typeface="Calibri" panose="020F0502020204030204" pitchFamily="34" charset="0"/>
               </a:rPr>
               <a:t>Natural change (births–deaths) </a:t>
             </a:r>
@@ -6035,7 +6074,7 @@
               <a:buChar char="•"/>
             </a:pPr>
             <a:endParaRPr lang="en-US" altLang="en-US" sz="3400" dirty="0">
-              <a:latin typeface="Arial" panose="020B0604020202020204" pitchFamily="34" charset="0"/>
+              <a:latin typeface="Calibri" panose="020F0502020204030204" pitchFamily="34" charset="0"/>
             </a:endParaRPr>
           </a:p>
           <a:p>
@@ -6051,7 +6090,7 @@
             </a:pPr>
             <a:r>
               <a:rPr lang="en-US" altLang="en-US" sz="3400" b="1" dirty="0">
-                <a:latin typeface="Arial" panose="020B0604020202020204" pitchFamily="34" charset="0"/>
+                <a:latin typeface="Calibri" panose="020F0502020204030204" pitchFamily="34" charset="0"/>
               </a:rPr>
               <a:t>Results Interpretation: </a:t>
             </a:r>
@@ -6069,7 +6108,7 @@
             </a:pPr>
             <a:r>
               <a:rPr lang="en-US" altLang="en-US" sz="3400" dirty="0">
-                <a:latin typeface="Arial" panose="020B0604020202020204" pitchFamily="34" charset="0"/>
+                <a:latin typeface="Calibri" panose="020F0502020204030204" pitchFamily="34" charset="0"/>
               </a:rPr>
               <a:t>Predictive population graphical representations</a:t>
             </a:r>
@@ -6084,7 +6123,7 @@
               </a:spcAft>
             </a:pPr>
             <a:endParaRPr lang="en-US" altLang="en-US" sz="3400" dirty="0">
-              <a:latin typeface="Arial" panose="020B0604020202020204" pitchFamily="34" charset="0"/>
+              <a:latin typeface="Calibri" panose="020F0502020204030204" pitchFamily="34" charset="0"/>
             </a:endParaRPr>
           </a:p>
           <a:p>
@@ -6169,7 +6208,7 @@
                 <a:ea typeface="Arial" charset="0"/>
                 <a:cs typeface="Arial" charset="0"/>
               </a:rPr>
-              <a:t>U.S. Census Bureau. Population Estimates Program (PEP): Puerto Rico Municipal Population Estimates, Vintage 2024.</a:t>
+              <a:t>U.S. Census Bureau. Population Estimates Program (PEP) Puerto Rico Municipal Population Estimates, Vintage 2024</a:t>
             </a:r>
             <a:endParaRPr lang="en-US" sz="3500" b="0" baseline="0" dirty="0">
               <a:latin typeface="Calibri" panose="020F0502020204030204" pitchFamily="34" charset="0"/>
@@ -6267,8 +6306,8 @@
         </p:blipFill>
         <p:spPr>
           <a:xfrm>
-            <a:off x="3175432" y="13796336"/>
-            <a:ext cx="9122463" cy="5656000"/>
+            <a:off x="3175433" y="13796336"/>
+            <a:ext cx="8577330" cy="5656000"/>
           </a:xfrm>
           <a:prstGeom prst="rect">
             <a:avLst/>
@@ -6276,38 +6315,6 @@
           <a:effectLst>
             <a:softEdge rad="127000"/>
           </a:effectLst>
-        </p:spPr>
-      </p:pic>
-      <p:pic>
-        <p:nvPicPr>
-          <p:cNvPr id="30" name="Picture 29" descr="A diagram of a model&#10;&#10;AI-generated content may be incorrect.">
-            <a:extLst>
-              <a:ext uri="{FF2B5EF4-FFF2-40B4-BE49-F238E27FC236}">
-                <a16:creationId xmlns:a16="http://schemas.microsoft.com/office/drawing/2014/main" id="{C4FEA899-F5B5-0E74-6FBC-369EAE51CB54}"/>
-              </a:ext>
-            </a:extLst>
-          </p:cNvPr>
-          <p:cNvPicPr>
-            <a:picLocks noChangeAspect="1"/>
-          </p:cNvPicPr>
-          <p:nvPr/>
-        </p:nvPicPr>
-        <p:blipFill>
-          <a:blip r:embed="rId5">
-            <a:alphaModFix amt="85000"/>
-          </a:blip>
-          <a:stretch>
-            <a:fillRect/>
-          </a:stretch>
-        </p:blipFill>
-        <p:spPr>
-          <a:xfrm>
-            <a:off x="16035554" y="26323695"/>
-            <a:ext cx="11543930" cy="5419871"/>
-          </a:xfrm>
-          <a:prstGeom prst="rect">
-            <a:avLst/>
-          </a:prstGeom>
         </p:spPr>
       </p:pic>
       <p:pic>
@@ -6325,7 +6332,7 @@
           <p:nvPr/>
         </p:nvPicPr>
         <p:blipFill>
-          <a:blip r:embed="rId6"/>
+          <a:blip r:embed="rId5"/>
           <a:stretch>
             <a:fillRect/>
           </a:stretch>
@@ -6358,7 +6365,7 @@
           <p:nvPr/>
         </p:nvPicPr>
         <p:blipFill>
-          <a:blip r:embed="rId7"/>
+          <a:blip r:embed="rId6"/>
           <a:stretch>
             <a:fillRect/>
           </a:stretch>
@@ -6391,7 +6398,7 @@
           <p:nvPr/>
         </p:nvPicPr>
         <p:blipFill>
-          <a:blip r:embed="rId8"/>
+          <a:blip r:embed="rId7"/>
           <a:srcRect l="11310" t="13705" r="3402" b="43365"/>
           <a:stretch>
             <a:fillRect/>
@@ -6399,7 +6406,7 @@
         </p:blipFill>
         <p:spPr>
           <a:xfrm>
-            <a:off x="29531733" y="20425541"/>
+            <a:off x="29573101" y="20446225"/>
             <a:ext cx="8187267" cy="3306309"/>
           </a:xfrm>
           <a:prstGeom prst="rect">
@@ -6422,7 +6429,7 @@
           <p:nvPr/>
         </p:nvPicPr>
         <p:blipFill>
-          <a:blip r:embed="rId9"/>
+          <a:blip r:embed="rId8"/>
           <a:srcRect t="24073" b="15494"/>
           <a:stretch>
             <a:fillRect/>
@@ -6453,7 +6460,7 @@
           <p:nvPr/>
         </p:nvPicPr>
         <p:blipFill>
-          <a:blip r:embed="rId10"/>
+          <a:blip r:embed="rId9"/>
           <a:srcRect l="1824" t="65520" r="45947"/>
           <a:stretch>
             <a:fillRect/>
@@ -6463,6 +6470,38 @@
           <a:xfrm>
             <a:off x="37908710" y="20459205"/>
             <a:ext cx="4423049" cy="2164019"/>
+          </a:xfrm>
+          <a:prstGeom prst="rect">
+            <a:avLst/>
+          </a:prstGeom>
+        </p:spPr>
+      </p:pic>
+      <p:pic>
+        <p:nvPicPr>
+          <p:cNvPr id="12" name="Picture 11" descr="A diagram of a model&#10;&#10;AI-generated content may be incorrect.">
+            <a:extLst>
+              <a:ext uri="{FF2B5EF4-FFF2-40B4-BE49-F238E27FC236}">
+                <a16:creationId xmlns:a16="http://schemas.microsoft.com/office/drawing/2014/main" id="{C0194460-1047-5873-AF1D-4ABB99D29563}"/>
+              </a:ext>
+            </a:extLst>
+          </p:cNvPr>
+          <p:cNvPicPr>
+            <a:picLocks noChangeAspect="1"/>
+          </p:cNvPicPr>
+          <p:nvPr/>
+        </p:nvPicPr>
+        <p:blipFill>
+          <a:blip r:embed="rId10">
+            <a:alphaModFix amt="85000"/>
+          </a:blip>
+          <a:stretch>
+            <a:fillRect/>
+          </a:stretch>
+        </p:blipFill>
+        <p:spPr>
+          <a:xfrm>
+            <a:off x="16151706" y="26323695"/>
+            <a:ext cx="11543930" cy="5461451"/>
           </a:xfrm>
           <a:prstGeom prst="rect">
             <a:avLst/>
@@ -7864,9 +7903,11 @@
 <ds:datastoreItem xmlns:ds="http://schemas.openxmlformats.org/officeDocument/2006/customXml" ds:itemID="{A0BD6F2F-D097-4693-BA4C-210A2E261A36}">
   <ds:schemaRefs>
     <ds:schemaRef ds:uri="http://schemas.microsoft.com/office/2006/metadata/properties"/>
+    <ds:schemaRef ds:uri="http://www.w3.org/2000/xmlns/"/>
+    <ds:schemaRef ds:uri="113e35d5-149a-42d0-9759-7e4251ca70ae"/>
     <ds:schemaRef ds:uri="http://schemas.microsoft.com/office/infopath/2007/PartnerControls"/>
-    <ds:schemaRef ds:uri="113e35d5-149a-42d0-9759-7e4251ca70ae"/>
     <ds:schemaRef ds:uri="7ea28f75-b447-4008-abb1-f022e6a61489"/>
+    <ds:schemaRef ds:uri="http://www.w3.org/2001/XMLSchema-instance"/>
   </ds:schemaRefs>
 </ds:datastoreItem>
 </file>
@@ -7884,10 +7925,11 @@
   <ds:schemaRefs>
     <ds:schemaRef ds:uri="http://schemas.microsoft.com/office/2006/metadata/contentType"/>
     <ds:schemaRef ds:uri="http://schemas.microsoft.com/office/2006/metadata/properties/metaAttributes"/>
+    <ds:schemaRef ds:uri="http://www.w3.org/2000/xmlns/"/>
     <ds:schemaRef ds:uri="http://www.w3.org/2001/XMLSchema"/>
-    <ds:schemaRef ds:uri="http://schemas.microsoft.com/office/2006/metadata/properties"/>
     <ds:schemaRef ds:uri="113e35d5-149a-42d0-9759-7e4251ca70ae"/>
     <ds:schemaRef ds:uri="7ea28f75-b447-4008-abb1-f022e6a61489"/>
+    <ds:schemaRef ds:uri="http://schemas.microsoft.com/office/2006/metadata/properties"/>
     <ds:schemaRef ds:uri="http://schemas.microsoft.com/office/2006/documentManagement/types"/>
     <ds:schemaRef ds:uri="http://schemas.microsoft.com/office/infopath/2007/PartnerControls"/>
     <ds:schemaRef ds:uri="http://schemas.openxmlformats.org/package/2006/metadata/core-properties"/>

</xml_diff>